<commit_message>
Last fixes: headlines say 'in final accuracy or forgetting'; slide 9 and slide 1 titles; XLand-MiniGrid reference confirmed
</commit_message>
<xml_diff>
--- a/presentation/NeuroPlast_final_review.pptx
+++ b/presentation/NeuroPlast_final_review.pptx
@@ -5404,7 +5404,7 @@
         <p:spPr>
           <a:xfrm>
             <a:off x="640080" y="1371600"/>
-            <a:ext cx="10789920" cy="1828800"/>
+            <a:ext cx="11247120" cy="1828800"/>
           </a:xfrm>
           <a:prstGeom prst="rect">
             <a:avLst/>
@@ -5423,13 +5423,29 @@
               </a:lnSpc>
             </a:pPr>
             <a:r>
-              <a:rPr sz="3600" b="1" i="0">
+              <a:rPr sz="3200" b="1" i="0">
                 <a:solidFill>
                   <a:srgbClr val="FFFFFF"/>
                 </a:solidFill>
                 <a:latin typeface="Cambria"/>
               </a:rPr>
-              <a:t>Testing Brain-Inspired Mechanisms for Task-Incremental Continual Reinforcement Learning</a:t>
+              <a:t>Testing Brain-Inspired Mechanisms for</a:t>
+            </a:r>
+          </a:p>
+          <a:p>
+            <a:pPr algn="l">
+              <a:lnSpc>
+                <a:spcPct val="100000"/>
+              </a:lnSpc>
+            </a:pPr>
+            <a:r>
+              <a:rPr sz="3200" b="1" i="0">
+                <a:solidFill>
+                  <a:srgbClr val="FFFFFF"/>
+                </a:solidFill>
+                <a:latin typeface="Cambria"/>
+              </a:rPr>
+              <a:t>Task-Incremental Continual Reinforcement Learning</a:t>
             </a:r>
           </a:p>
         </p:txBody>
@@ -12765,7 +12781,11 @@
           </a:bodyPr>
           <a:lstStyle/>
           <a:p>
-            <a:pPr algn="l"/>
+            <a:pPr algn="l">
+              <a:lnSpc>
+                <a:spcPct val="100000"/>
+              </a:lnSpc>
+            </a:pPr>
             <a:r>
               <a:rPr sz="2800" b="1" i="0">
                 <a:solidFill>
@@ -12773,7 +12793,7 @@
                 </a:solidFill>
                 <a:latin typeface="Cambria"/>
               </a:rPr>
-              <a:t>No statistically reliable improvement beyond the matched controls</a:t>
+              <a:t>No statistically reliable improvement in final accuracy or forgetting beyond the matched controls</a:t>
             </a:r>
           </a:p>
         </p:txBody>
@@ -12786,7 +12806,7 @@
         </p:nvSpPr>
         <p:spPr>
           <a:xfrm>
-            <a:off x="640080" y="1691640"/>
+            <a:off x="640080" y="2057400"/>
             <a:ext cx="10972800" cy="457200"/>
           </a:xfrm>
           <a:prstGeom prst="rect">
@@ -12821,7 +12841,7 @@
         </p:nvSpPr>
         <p:spPr>
           <a:xfrm>
-            <a:off x="640080" y="2532888"/>
+            <a:off x="640080" y="2743200"/>
             <a:ext cx="384048" cy="384048"/>
           </a:xfrm>
           <a:prstGeom prst="ellipse">
@@ -12864,7 +12884,7 @@
         </p:nvSpPr>
         <p:spPr>
           <a:xfrm>
-            <a:off x="640080" y="2532888"/>
+            <a:off x="640080" y="2743200"/>
             <a:ext cx="384048" cy="384048"/>
           </a:xfrm>
           <a:prstGeom prst="rect">
@@ -12899,7 +12919,7 @@
         </p:nvSpPr>
         <p:spPr>
           <a:xfrm>
-            <a:off x="1234440" y="2496312"/>
+            <a:off x="1234440" y="2706624"/>
             <a:ext cx="2103120" cy="411480"/>
           </a:xfrm>
           <a:prstGeom prst="rect">
@@ -12934,7 +12954,7 @@
         </p:nvSpPr>
         <p:spPr>
           <a:xfrm>
-            <a:off x="3291840" y="2478024"/>
+            <a:off x="3291840" y="2688336"/>
             <a:ext cx="8321040" cy="731520"/>
           </a:xfrm>
           <a:prstGeom prst="rect">
@@ -12969,7 +12989,7 @@
         </p:nvSpPr>
         <p:spPr>
           <a:xfrm>
-            <a:off x="640080" y="3337560"/>
+            <a:off x="640080" y="3502152"/>
             <a:ext cx="384048" cy="384048"/>
           </a:xfrm>
           <a:prstGeom prst="ellipse">
@@ -13012,7 +13032,7 @@
         </p:nvSpPr>
         <p:spPr>
           <a:xfrm>
-            <a:off x="640080" y="3337560"/>
+            <a:off x="640080" y="3502152"/>
             <a:ext cx="384048" cy="384048"/>
           </a:xfrm>
           <a:prstGeom prst="rect">
@@ -13047,7 +13067,7 @@
         </p:nvSpPr>
         <p:spPr>
           <a:xfrm>
-            <a:off x="1234440" y="3300984"/>
+            <a:off x="1234440" y="3465576"/>
             <a:ext cx="2103120" cy="411480"/>
           </a:xfrm>
           <a:prstGeom prst="rect">
@@ -13082,7 +13102,7 @@
         </p:nvSpPr>
         <p:spPr>
           <a:xfrm>
-            <a:off x="3291840" y="3282696"/>
+            <a:off x="3291840" y="3447288"/>
             <a:ext cx="8321040" cy="731520"/>
           </a:xfrm>
           <a:prstGeom prst="rect">
@@ -13117,7 +13137,7 @@
         </p:nvSpPr>
         <p:spPr>
           <a:xfrm>
-            <a:off x="640080" y="4142231"/>
+            <a:off x="640080" y="4261103"/>
             <a:ext cx="384048" cy="384048"/>
           </a:xfrm>
           <a:prstGeom prst="ellipse">
@@ -13160,7 +13180,7 @@
         </p:nvSpPr>
         <p:spPr>
           <a:xfrm>
-            <a:off x="640080" y="4142231"/>
+            <a:off x="640080" y="4261103"/>
             <a:ext cx="384048" cy="384048"/>
           </a:xfrm>
           <a:prstGeom prst="rect">
@@ -13195,7 +13215,7 @@
         </p:nvSpPr>
         <p:spPr>
           <a:xfrm>
-            <a:off x="1234440" y="4105656"/>
+            <a:off x="1234440" y="4224528"/>
             <a:ext cx="2103120" cy="411480"/>
           </a:xfrm>
           <a:prstGeom prst="rect">
@@ -13230,7 +13250,7 @@
         </p:nvSpPr>
         <p:spPr>
           <a:xfrm>
-            <a:off x="3291840" y="4087368"/>
+            <a:off x="3291840" y="4206240"/>
             <a:ext cx="8321040" cy="731520"/>
           </a:xfrm>
           <a:prstGeom prst="rect">
@@ -13265,7 +13285,7 @@
         </p:nvSpPr>
         <p:spPr>
           <a:xfrm>
-            <a:off x="640080" y="4946904"/>
+            <a:off x="640080" y="5020055"/>
             <a:ext cx="384048" cy="384048"/>
           </a:xfrm>
           <a:prstGeom prst="ellipse">
@@ -13308,7 +13328,7 @@
         </p:nvSpPr>
         <p:spPr>
           <a:xfrm>
-            <a:off x="640080" y="4946904"/>
+            <a:off x="640080" y="5020055"/>
             <a:ext cx="384048" cy="384048"/>
           </a:xfrm>
           <a:prstGeom prst="rect">
@@ -13343,7 +13363,7 @@
         </p:nvSpPr>
         <p:spPr>
           <a:xfrm>
-            <a:off x="1234440" y="4910328"/>
+            <a:off x="1234440" y="4983480"/>
             <a:ext cx="2103120" cy="411480"/>
           </a:xfrm>
           <a:prstGeom prst="rect">
@@ -13378,7 +13398,7 @@
         </p:nvSpPr>
         <p:spPr>
           <a:xfrm>
-            <a:off x="3291840" y="4892040"/>
+            <a:off x="3291840" y="4965192"/>
             <a:ext cx="8321040" cy="731520"/>
           </a:xfrm>
           <a:prstGeom prst="rect">
@@ -22964,7 +22984,7 @@
                 </a:solidFill>
                 <a:latin typeface="Cambria"/>
               </a:rPr>
-              <a:t>No reliable improvement beyond the matched controls</a:t>
+              <a:t>No reliable improvement in final accuracy or forgetting beyond the matched controls</a:t>
             </a:r>
           </a:p>
         </p:txBody>
@@ -22977,7 +22997,7 @@
         </p:nvSpPr>
         <p:spPr>
           <a:xfrm>
-            <a:off x="731520" y="1719072"/>
+            <a:off x="731520" y="1810512"/>
             <a:ext cx="3291840" cy="274320"/>
           </a:xfrm>
           <a:prstGeom prst="rect">
@@ -23012,7 +23032,7 @@
         </p:nvSpPr>
         <p:spPr>
           <a:xfrm>
-            <a:off x="3840480" y="1719072"/>
+            <a:off x="3840480" y="1810512"/>
             <a:ext cx="3108960" cy="274320"/>
           </a:xfrm>
           <a:prstGeom prst="rect">
@@ -23047,7 +23067,7 @@
         </p:nvSpPr>
         <p:spPr>
           <a:xfrm>
-            <a:off x="7178040" y="1719072"/>
+            <a:off x="7178040" y="1810512"/>
             <a:ext cx="4572000" cy="274320"/>
           </a:xfrm>
           <a:prstGeom prst="rect">
@@ -23082,8 +23102,8 @@
         </p:nvSpPr>
         <p:spPr>
           <a:xfrm>
-            <a:off x="548640" y="2057400"/>
-            <a:ext cx="11094415" cy="512064"/>
+            <a:off x="548640" y="2148840"/>
+            <a:ext cx="11094415" cy="493776"/>
           </a:xfrm>
           <a:prstGeom prst="roundRect">
             <a:avLst>
@@ -23126,8 +23146,8 @@
         </p:nvSpPr>
         <p:spPr>
           <a:xfrm>
-            <a:off x="731520" y="2057400"/>
-            <a:ext cx="3200400" cy="512064"/>
+            <a:off x="731520" y="2148840"/>
+            <a:ext cx="3200400" cy="493776"/>
           </a:xfrm>
           <a:prstGeom prst="rect">
             <a:avLst/>
@@ -23161,7 +23181,7 @@
         </p:nvSpPr>
         <p:spPr>
           <a:xfrm>
-            <a:off x="3840480" y="2148840"/>
+            <a:off x="3840480" y="2240280"/>
             <a:ext cx="3154680" cy="365760"/>
           </a:xfrm>
           <a:prstGeom prst="roundRect">
@@ -23216,8 +23236,8 @@
         </p:nvSpPr>
         <p:spPr>
           <a:xfrm>
-            <a:off x="7178040" y="2057400"/>
-            <a:ext cx="4373575" cy="512064"/>
+            <a:off x="7178040" y="2148840"/>
+            <a:ext cx="4373575" cy="493776"/>
           </a:xfrm>
           <a:prstGeom prst="rect">
             <a:avLst/>
@@ -23251,8 +23271,8 @@
         </p:nvSpPr>
         <p:spPr>
           <a:xfrm>
-            <a:off x="548640" y="2660904"/>
-            <a:ext cx="11094415" cy="512064"/>
+            <a:off x="548640" y="2734056"/>
+            <a:ext cx="11094415" cy="493776"/>
           </a:xfrm>
           <a:prstGeom prst="roundRect">
             <a:avLst>
@@ -23295,8 +23315,8 @@
         </p:nvSpPr>
         <p:spPr>
           <a:xfrm>
-            <a:off x="731520" y="2660904"/>
-            <a:ext cx="3200400" cy="512064"/>
+            <a:off x="731520" y="2734056"/>
+            <a:ext cx="3200400" cy="493776"/>
           </a:xfrm>
           <a:prstGeom prst="rect">
             <a:avLst/>
@@ -23330,7 +23350,7 @@
         </p:nvSpPr>
         <p:spPr>
           <a:xfrm>
-            <a:off x="3840480" y="2752344"/>
+            <a:off x="3840480" y="2825496"/>
             <a:ext cx="3154680" cy="365760"/>
           </a:xfrm>
           <a:prstGeom prst="roundRect">
@@ -23385,8 +23405,8 @@
         </p:nvSpPr>
         <p:spPr>
           <a:xfrm>
-            <a:off x="7178040" y="2660904"/>
-            <a:ext cx="4373575" cy="512064"/>
+            <a:off x="7178040" y="2734056"/>
+            <a:ext cx="4373575" cy="493776"/>
           </a:xfrm>
           <a:prstGeom prst="rect">
             <a:avLst/>
@@ -23420,8 +23440,8 @@
         </p:nvSpPr>
         <p:spPr>
           <a:xfrm>
-            <a:off x="548640" y="3264408"/>
-            <a:ext cx="11094415" cy="512064"/>
+            <a:off x="548640" y="3319272"/>
+            <a:ext cx="11094415" cy="493776"/>
           </a:xfrm>
           <a:prstGeom prst="roundRect">
             <a:avLst>
@@ -23464,8 +23484,8 @@
         </p:nvSpPr>
         <p:spPr>
           <a:xfrm>
-            <a:off x="731520" y="3264408"/>
-            <a:ext cx="3200400" cy="512064"/>
+            <a:off x="731520" y="3319272"/>
+            <a:ext cx="3200400" cy="493776"/>
           </a:xfrm>
           <a:prstGeom prst="rect">
             <a:avLst/>
@@ -23499,7 +23519,7 @@
         </p:nvSpPr>
         <p:spPr>
           <a:xfrm>
-            <a:off x="3840480" y="3355848"/>
+            <a:off x="3840480" y="3410712"/>
             <a:ext cx="3154680" cy="365760"/>
           </a:xfrm>
           <a:prstGeom prst="roundRect">
@@ -23554,8 +23574,8 @@
         </p:nvSpPr>
         <p:spPr>
           <a:xfrm>
-            <a:off x="7178040" y="3264408"/>
-            <a:ext cx="4373575" cy="512064"/>
+            <a:off x="7178040" y="3319272"/>
+            <a:ext cx="4373575" cy="493776"/>
           </a:xfrm>
           <a:prstGeom prst="rect">
             <a:avLst/>
@@ -23589,8 +23609,8 @@
         </p:nvSpPr>
         <p:spPr>
           <a:xfrm>
-            <a:off x="548640" y="3867912"/>
-            <a:ext cx="11094415" cy="512064"/>
+            <a:off x="548640" y="3904487"/>
+            <a:ext cx="11094415" cy="493776"/>
           </a:xfrm>
           <a:prstGeom prst="roundRect">
             <a:avLst>
@@ -23633,8 +23653,8 @@
         </p:nvSpPr>
         <p:spPr>
           <a:xfrm>
-            <a:off x="731520" y="3867912"/>
-            <a:ext cx="3200400" cy="512064"/>
+            <a:off x="731520" y="3904487"/>
+            <a:ext cx="3200400" cy="493776"/>
           </a:xfrm>
           <a:prstGeom prst="rect">
             <a:avLst/>
@@ -23668,7 +23688,7 @@
         </p:nvSpPr>
         <p:spPr>
           <a:xfrm>
-            <a:off x="3840480" y="3959352"/>
+            <a:off x="3840480" y="3995927"/>
             <a:ext cx="3154680" cy="365760"/>
           </a:xfrm>
           <a:prstGeom prst="roundRect">
@@ -23723,8 +23743,8 @@
         </p:nvSpPr>
         <p:spPr>
           <a:xfrm>
-            <a:off x="7178040" y="3867912"/>
-            <a:ext cx="4373575" cy="512064"/>
+            <a:off x="7178040" y="3904487"/>
+            <a:ext cx="4373575" cy="493776"/>
           </a:xfrm>
           <a:prstGeom prst="rect">
             <a:avLst/>
@@ -23758,8 +23778,8 @@
         </p:nvSpPr>
         <p:spPr>
           <a:xfrm>
-            <a:off x="548640" y="4471416"/>
-            <a:ext cx="11094415" cy="512064"/>
+            <a:off x="548640" y="4489704"/>
+            <a:ext cx="11094415" cy="493776"/>
           </a:xfrm>
           <a:prstGeom prst="roundRect">
             <a:avLst>
@@ -23802,8 +23822,8 @@
         </p:nvSpPr>
         <p:spPr>
           <a:xfrm>
-            <a:off x="731520" y="4471416"/>
-            <a:ext cx="3200400" cy="512064"/>
+            <a:off x="731520" y="4489704"/>
+            <a:ext cx="3200400" cy="493776"/>
           </a:xfrm>
           <a:prstGeom prst="rect">
             <a:avLst/>
@@ -23837,7 +23857,7 @@
         </p:nvSpPr>
         <p:spPr>
           <a:xfrm>
-            <a:off x="3840480" y="4562856"/>
+            <a:off x="3840480" y="4581144"/>
             <a:ext cx="3154680" cy="365760"/>
           </a:xfrm>
           <a:prstGeom prst="roundRect">
@@ -23892,8 +23912,8 @@
         </p:nvSpPr>
         <p:spPr>
           <a:xfrm>
-            <a:off x="7178040" y="4471416"/>
-            <a:ext cx="4373575" cy="512064"/>
+            <a:off x="7178040" y="4489704"/>
+            <a:ext cx="4373575" cy="493776"/>
           </a:xfrm>
           <a:prstGeom prst="rect">
             <a:avLst/>
@@ -23928,7 +23948,7 @@
         <p:spPr>
           <a:xfrm>
             <a:off x="548640" y="5074920"/>
-            <a:ext cx="11094415" cy="512064"/>
+            <a:ext cx="11094415" cy="493776"/>
           </a:xfrm>
           <a:prstGeom prst="roundRect">
             <a:avLst>
@@ -23972,7 +23992,7 @@
         <p:spPr>
           <a:xfrm>
             <a:off x="731520" y="5074920"/>
-            <a:ext cx="3200400" cy="512064"/>
+            <a:ext cx="3200400" cy="493776"/>
           </a:xfrm>
           <a:prstGeom prst="rect">
             <a:avLst/>
@@ -24062,7 +24082,7 @@
         <p:spPr>
           <a:xfrm>
             <a:off x="7178040" y="5074920"/>
-            <a:ext cx="4373575" cy="512064"/>
+            <a:ext cx="4373575" cy="493776"/>
           </a:xfrm>
           <a:prstGeom prst="rect">
             <a:avLst/>
@@ -24096,8 +24116,8 @@
         </p:nvSpPr>
         <p:spPr>
           <a:xfrm>
-            <a:off x="548640" y="5678424"/>
-            <a:ext cx="11094415" cy="512064"/>
+            <a:off x="548640" y="5660136"/>
+            <a:ext cx="11094415" cy="493776"/>
           </a:xfrm>
           <a:prstGeom prst="roundRect">
             <a:avLst>
@@ -24140,8 +24160,8 @@
         </p:nvSpPr>
         <p:spPr>
           <a:xfrm>
-            <a:off x="731520" y="5678424"/>
-            <a:ext cx="3200400" cy="512064"/>
+            <a:off x="731520" y="5660136"/>
+            <a:ext cx="3200400" cy="493776"/>
           </a:xfrm>
           <a:prstGeom prst="rect">
             <a:avLst/>
@@ -24175,7 +24195,7 @@
         </p:nvSpPr>
         <p:spPr>
           <a:xfrm>
-            <a:off x="3840480" y="5769864"/>
+            <a:off x="3840480" y="5751575"/>
             <a:ext cx="3154680" cy="365760"/>
           </a:xfrm>
           <a:prstGeom prst="roundRect">
@@ -24230,8 +24250,8 @@
         </p:nvSpPr>
         <p:spPr>
           <a:xfrm>
-            <a:off x="7178040" y="5678424"/>
-            <a:ext cx="4373575" cy="512064"/>
+            <a:off x="7178040" y="5660136"/>
+            <a:ext cx="4373575" cy="493776"/>
           </a:xfrm>
           <a:prstGeom prst="rect">
             <a:avLst/>
@@ -24830,7 +24850,7 @@
                 </a:solidFill>
                 <a:latin typeface="Cambria"/>
               </a:rPr>
-              <a:t>A shared trunk is competitive only with a small buffer and full-width isolation</a:t>
+              <a:t>A shared trunk is competitive only with a small buffer, and only against full-width isolation</a:t>
             </a:r>
           </a:p>
         </p:txBody>

</xml_diff>